<commit_message>
자동 동기화 2026-06-10 23:00:25
</commit_message>
<xml_diff>
--- a/발표준비/발표자료_초원생태계.pptx
+++ b/발표준비/발표자료_초원생태계.pptx
@@ -686,7 +686,8 @@
           <a:p>
             <a:r>
               <a:rPr lang="en-US" dirty="0"/>
-              <a:t>(심성진 파트 대신 구조 설명) Entity가 최상위 — 물리엔진·GUI가 동물·식물·트랙터를 동일하게 다룬다. Animal의 update()는 템플릿 메서드: 타이머→허기→act()→이동→죽음 판정의 공통 흐름을 고정하고, 종마다 다른 행동은 추상 메서드 act()만 구현한다. 초식은 rp_rate/reproduce(번식), 육식은 energy/attack(공격과 먹기의 분리). 색은 담당 조원을 나타낸다.</a:t>
+              <a:t>[클래스 다이어그램 대본 · 약 1분 5초 — 심성진 파트(부모 클래스·월드) 대체, 첫 발표자가 낭독]
+파트 설명에 앞서 전체 클래스 구조를 소개하겠습니다. 저희 코드의 모든 구성원은 하나의 상속 트리 위에 있습니다. 최상위에는 추상 클래스 Entity가 있어 위치, 생존 여부, 그리고 매 틱 호출되는 update라는 공통 인터페이스를 정의합니다. 덕분에 물리엔진과 화면이 동물이든 식물이든 트랙터든 똑같은 방식으로 다룰 수 있습니다. 그 아래 Animal은 속도, 체력, 공격력, 회복력, 허기라는 공통 속성과 함께 '템플릿 메서드 패턴'을 구현합니다. update가 타이머 감소, 허기 증가, 행동 결정, 이동, 죽음 판정이라는 공통 흐름을 고정하고, 종마다 다른 행동은 추상 메서드 act 하나에만 맡기는 구조라서, 새로운 동물을 추가할 때는 act만 구현하면 됩니다. Animal 아래는 번식 게이지와 reproduce를 가진 초식동물 Herbivore, 기력과 attack을 가진 육식동물 Carnivore로 갈라지고, 그 아래 토끼, 기린, 얼룩말, 코끼리, 사자, 치타, 하이에나 일곱 종이 각자 고유 능력 메서드 하나씩을 더합니다. 식물은 Plant 아래 풀과 나무가 있는데, 풀은 먹이이자 토끼의 은신처, 나무는 모든 번식이 일어나는 만남의 장소입니다. 이렇게 '공통은 위로, 차이는 아래로' 보내는 상속 설계 덕분에 네 명이 코드 중복 없이 분업할 수 있었습니다.</a:t>
             </a:r>
             <a:endParaRPr lang="en-US" dirty="0"/>
           </a:p>
@@ -774,7 +775,7 @@
           <a:p>
             <a:r>
               <a:rPr lang="en-US" dirty="0"/>
-              <a:t>개발 순서: ①홍순율이 벡터→물리엔진→설정으로 기반(의존성 없음) ②심성진이 Entity·Animal·Carnivore로 인터페이스를 고정, 한시헌이 같은 파일에 Herbivore·Plant ③고정 즉시 세 명이 동시에 구체 동물 작성 ④심성진 world + 심준서 interactions 병렬 ⑤한시헌 gui + 홍순율 disaster·main ⑥다 함께 통합·밸런싱.</a:t>
+              <a:t>개발 순서: ①홍순율이 벡터→물리엔진→설정으로 기반(의존성 없음) ②심성진이 Entity·Animal·Carnivore로 인터페이스를 고정, 한시헌이 같은 파일에 Herbivore·Plant ③고정 즉시 세 명이 동시에 구체 동물 작성(심준서 육식 / 한시헌 식물·토끼·기린 / 심성진 얼룩말·코끼리) ④심성진 world + 심준서 interactions 병렬 ⑤홍순율이 disaster→gui→main으로 종료·화면·진입점 완성 ⑥다 함께 통합·밸런싱.</a:t>
             </a:r>
             <a:endParaRPr lang="en-US" dirty="0"/>
           </a:p>
@@ -863,7 +864,7 @@
             <a:r>
               <a:rPr lang="en-US" dirty="0"/>
               <a:t>[대본 · 약 1분 25초]
-안녕하세요, 물리엔진과 프로그램의 뼈대를 맡은 홍순율입니다. 저희 프로젝트는 외부 라이브러리 없이 100% 파이썬 표준 라이브러리로 만들었기 때문에, 물리엔진도 직접 구현해야 했습니다. 먼저 vector.py에서 2차원 벡터 클래스를 만들고 연산자 오버로딩을 적용해서, 물리 공식을 '위치 더하기 속도 곱하기 시간'처럼 수식 그대로 코드에 쓸 수 있게 했습니다. physics.py의 핵심은 '결정과 실행의 분리'입니다. seek, flee, wander 같은 조향 함수가 '어디로 갈지' 속도 벡터만 정해 주면, integrate 함수가 오일러 적분으로 실제 위치에 반영합니다. 충돌은 모든 개체를 원으로 보고 판정하는데, 제곱근 계산이 느리기 때문에 거리의 제곱끼리 비교하는 최적화도 적용했습니다. 마지막으로 disaster.py는 종료 조건인 트랙터 재난입니다. D키를 누르면 트랙터 무리가 초원 전체 높이를 빈틈없이 덮도록 계산되어 등장하고, 화면을 가로지르며 닿는 모든 생물을 밀어버립니다. 종료를 단순한 스위치가 아니라 '시간의 흐름에 따라 관찰되는 사건'으로 만든 것이 제 파트의 포인트입니다.</a:t>
+안녕하세요, 물리엔진과 화면, 프로그램의 시작과 끝을 맡은 홍순율입니다. 저희는 외부 라이브러리 없이 100% 파이썬 표준 라이브러리로 만들었기 때문에 물리엔진도 직접 구현했습니다. vector.py의 2차원 벡터 클래스에 연산자 오버로딩을 적용해 물리 공식을 '위치 더하기 속도 곱하기 시간'처럼 수식 그대로 쓸 수 있게 했고, physics.py는 '결정과 실행의 분리'가 핵심입니다. seek, flee 같은 조향 함수가 어디로 갈지 속도만 정하면 integrate가 오일러 적분으로 위치에 반영하고, 충돌은 모든 개체를 원으로 보고 제곱거리 비교로 빠르게 판정합니다. 화면도 제가 만들었습니다. gui.py는 tkinter만으로, while 루프 대신 after 예약 방식의 게임 루프를 써서 매 프레임 월드를 한 틱 진행하고 다시 그립니다. 체력바, 기절 표시, 개체 수 통계, 생태계 일지로 변화가 한눈에 보이고, 한글 입력 상태에서 키가 안 먹는 문제까지 처리했습니다. 마지막 disaster.py의 트랙터 재난은, D키를 누르면 트랙터 무리가 초원 전체 높이를 덮도록 계산되어 등장해 화면을 가로지르며 모든 생물을 밀어버리는 종료 조건입니다. 종료를 스위치가 아니라 시간의 흐름으로 관찰되는 사건으로 만든 것이 포인트입니다.</a:t>
             </a:r>
             <a:endParaRPr lang="en-US" dirty="0"/>
           </a:p>
@@ -1040,8 +1041,8 @@
           <a:p>
             <a:r>
               <a:rPr lang="en-US" dirty="0"/>
-              <a:t>[대본 · 약 1분 25초]
-초식동물과 식물, 그리고 화면 출력을 맡은 한시헌입니다. 저는 모든 초식동물이 상속받는 Herbivore 부모 클래스에 공통 생존 흐름을 구현했습니다. 포식자가 가까우면 도망가고, 배고프면 풀을 찾고, 번식 준비가 되면 나무로 모이는 순서입니다. 특히 모든 동물이 가장 가까운 나무 한곳에 몰려 겹쳐 보이던 문제를, '덜 붐비는 나무를 고르고, 나무 중심이 아니라 둘레의 자기 자리로 가게' 해서 해결했습니다. 토끼는 위험하면 근처 풀숲에 숨는 hide 능력이 있는데, 풀 하나에 숨을 수 있는 토끼 수에 한계를 둬서 현실성을 살렸고, 기린은 넥스윙으로 포식자를 밀쳐냅니다. 화면은 외부 라이브러리 없이 tkinter만으로 만들었습니다. while 루프 대신 after 예약 방식으로 매 프레임 월드를 한 틱 진행하고 다시 그리는 게임 루프 구조입니다. 동물 머리 위 체력바, 기절한 포식자의 노란 고리, 종별 개체 수 통계와 생태계 일지 로그로, 시간의 흐름에 따른 생태계 변화를 한눈에 볼 수 있게 했습니다. 한글 입력 상태에서 키가 안 먹는 문제까지 처리해서 어떤 상태에서도 조작이 됩니다.</a:t>
+              <a:t>[대본 · 약 1분 20초]
+초식동물과 식물을 맡은 한시헌입니다. 모든 초식동물이 상속받는 Herbivore 부모 클래스에 공통 생존 흐름을 구현했습니다. 포식자가 가까우면 도망가고, 배고프면 풀을 찾고, 번식 준비가 되면 나무로 모이는 순서입니다. 제가 가장 공들인 부분은 번식터 분산 알고리즘입니다. 처음에는 모든 동물이 가장 가까운 나무 한곳에 몰려 화면이 겹쳐 보였는데, 가까운 나무 몇 개 중 덜 붐비는 곳을 고르고, 나무 중심이 아니라 둘레의 자기 자리로 가게 해서 번식 조건은 유지하면서 군집 문제를 해결했습니다. 번식 메서드는 type(self)로 자기와 같은 종을 생성하기 때문에 토끼는 토끼를, 기린은 기린을 낳고, 자식 클래스마다 번식 코드를 다시 쓸 필요가 없습니다. 토끼는 위험하면 근처 풀숲에 숨는 hide 능력이 있는데, 숨는 동안 포식자에게 보이지 않고, 풀 하나에 숨을 수 있는 토끼 수에 한계를 둬 현실성을 살렸습니다. 기린은 넥스윙으로 포식자를 밀쳐내며 피해를 주는데, 같은 메서드가 기린끼리의 싸움에도 재사용됩니다. 식물 쪽에서는 풀이 be_eaten 메서드로 자기 먹이량을 스스로 관리하고 다 뜯기면 120틱 뒤 다시 자라며, 나무는 모든 번식이 일어나는 만남의 장소가 됩니다.</a:t>
             </a:r>
             <a:endParaRPr lang="en-US" dirty="0"/>
           </a:p>
@@ -5460,7 +5461,7 @@
             <a:avLst/>
           </a:prstGeom>
           <a:solidFill>
-            <a:srgbClr val="97BC62"/>
+            <a:srgbClr val="44617B"/>
           </a:solidFill>
           <a:ln/>
         </p:spPr>
@@ -5563,7 +5564,7 @@
                 <a:ea typeface="Apple SD Gothic Neo" pitchFamily="34" charset="-122"/>
                 <a:cs typeface="Apple SD Gothic Neo" pitchFamily="34" charset="-120"/>
               </a:rPr>
-              <a:t>gui.py / disaster</a:t>
+              <a:t>disaster → gui</a:t>
             </a:r>
             <a:endParaRPr lang="en-US" sz="1350" dirty="0"/>
           </a:p>
@@ -5583,7 +5584,7 @@
                 <a:ea typeface="Apple SD Gothic Neo" pitchFamily="34" charset="-122"/>
                 <a:cs typeface="Apple SD Gothic Neo" pitchFamily="34" charset="-120"/>
               </a:rPr>
-              <a:t>main.py</a:t>
+              <a:t>→ main.py</a:t>
             </a:r>
             <a:endParaRPr lang="en-US" sz="1350" dirty="0"/>
           </a:p>
@@ -5597,13 +5598,13 @@
             <a:r>
               <a:rPr lang="en-US" sz="1050" b="1" dirty="0">
                 <a:solidFill>
-                  <a:srgbClr val="2C5F2D"/>
-                </a:solidFill>
-                <a:latin typeface="Apple SD Gothic Neo" pitchFamily="34" charset="0"/>
-                <a:ea typeface="Apple SD Gothic Neo" pitchFamily="34" charset="-122"/>
-                <a:cs typeface="Apple SD Gothic Neo" pitchFamily="34" charset="-120"/>
-              </a:rPr>
-              <a:t>한시헌 + 홍순율</a:t>
+                  <a:srgbClr val="44617B"/>
+                </a:solidFill>
+                <a:latin typeface="Apple SD Gothic Neo" pitchFamily="34" charset="0"/>
+                <a:ea typeface="Apple SD Gothic Neo" pitchFamily="34" charset="-122"/>
+                <a:cs typeface="Apple SD Gothic Neo" pitchFamily="34" charset="-120"/>
+              </a:rPr>
+              <a:t>홍순율</a:t>
             </a:r>
             <a:endParaRPr lang="en-US" sz="1350" dirty="0"/>
           </a:p>
@@ -5929,7 +5930,7 @@
                 <a:ea typeface="Apple SD Gothic Neo" pitchFamily="34" charset="-122"/>
                 <a:cs typeface="Apple SD Gothic Neo" pitchFamily="34" charset="-120"/>
               </a:rPr>
-              <a:t>① 홍순율 — 직접 구현한 물리엔진, 그리고 시작과 끝</a:t>
+              <a:t>① 홍순율 — 물리엔진과 화면, 그리고 시작과 끝</a:t>
             </a:r>
             <a:endParaRPr lang="en-US" sz="2600" dirty="0"/>
           </a:p>
@@ -5968,7 +5969,7 @@
                 <a:ea typeface="Apple SD Gothic Neo" pitchFamily="34" charset="-122"/>
                 <a:cs typeface="Apple SD Gothic Neo" pitchFamily="34" charset="-120"/>
               </a:rPr>
-              <a:t>vector.py · physics.py · config.py · disaster.py · main.py</a:t>
+              <a:t>vector.py · physics.py · config.py · gui.py · disaster.py · main.py</a:t>
             </a:r>
             <a:endParaRPr lang="en-US" sz="1200" dirty="0"/>
           </a:p>
@@ -6365,7 +6366,7 @@
                 <a:ea typeface="Apple SD Gothic Neo" pitchFamily="34" charset="-122"/>
                 <a:cs typeface="Apple SD Gothic Neo" pitchFamily="34" charset="-120"/>
               </a:rPr>
-              <a:t>◎</a:t>
+              <a:t>🖥</a:t>
             </a:r>
             <a:endParaRPr lang="en-US" sz="1400" dirty="0"/>
           </a:p>
@@ -6407,7 +6408,7 @@
                 <a:ea typeface="Apple SD Gothic Neo" pitchFamily="34" charset="-122"/>
                 <a:cs typeface="Apple SD Gothic Neo" pitchFamily="34" charset="-120"/>
               </a:rPr>
-              <a:t>원-원 충돌 + 제곱거리 최적화</a:t>
+              <a:t>tkinter만으로 만든 GUI</a:t>
             </a:r>
             <a:endParaRPr lang="en-US" sz="1250" dirty="0"/>
           </a:p>
@@ -6427,7 +6428,7 @@
                 <a:ea typeface="Apple SD Gothic Neo" pitchFamily="34" charset="-122"/>
                 <a:cs typeface="Apple SD Gothic Neo" pitchFamily="34" charset="-120"/>
               </a:rPr>
-              <a:t>모든 개체를 원으로 보고 충돌 판정. sqrt를 피하려 거리의 제곱끼리 비교 — 매 틱 수백 번 호출되는 곳의 최적화.</a:t>
+              <a:t>after() 게임 루프 — 매 프레임 한 틱 + 다시 그리기. 체력바·기절 고리·통계·일지 시각화, 한/영 키 문제까지 해결.</a:t>
             </a:r>
             <a:endParaRPr lang="en-US" sz="1250" dirty="0"/>
           </a:p>
@@ -7466,7 +7467,7 @@
                 <a:ea typeface="Apple SD Gothic Neo" pitchFamily="34" charset="-122"/>
                 <a:cs typeface="Apple SD Gothic Neo" pitchFamily="34" charset="-120"/>
               </a:rPr>
-              <a:t>③ 한시헌 — 초식동물의 생존 본능과 살아 있는 화면</a:t>
+              <a:t>③ 한시헌 — 초식동물의 생존 본능과 식물</a:t>
             </a:r>
             <a:endParaRPr lang="en-US" sz="2600" dirty="0"/>
           </a:p>
@@ -7505,7 +7506,7 @@
                 <a:ea typeface="Apple SD Gothic Neo" pitchFamily="34" charset="-122"/>
                 <a:cs typeface="Apple SD Gothic Neo" pitchFamily="34" charset="-120"/>
               </a:rPr>
-              <a:t>organisms.py(Herbivore·Plant) · herbivores.py(토끼·기린) · plants.py · gui.py</a:t>
+              <a:t>organisms.py(Herbivore·Plant) · herbivores.py(토끼·기린) · plants.py</a:t>
             </a:r>
             <a:endParaRPr lang="en-US" sz="1200" dirty="0"/>
           </a:p>
@@ -7703,7 +7704,7 @@
                 <a:ea typeface="Apple SD Gothic Neo" pitchFamily="34" charset="-122"/>
                 <a:cs typeface="Apple SD Gothic Neo" pitchFamily="34" charset="-120"/>
               </a:rPr>
-              <a:t>🌳</a:t>
+              <a:t>🌿</a:t>
             </a:r>
             <a:endParaRPr lang="en-US" sz="2200" dirty="0"/>
           </a:p>
@@ -7742,7 +7743,7 @@
                 <a:ea typeface="Apple SD Gothic Neo" pitchFamily="34" charset="-122"/>
                 <a:cs typeface="Apple SD Gothic Neo" pitchFamily="34" charset="-120"/>
               </a:rPr>
-              <a:t>번식터 분산 알고리즘</a:t>
+              <a:t>풀의 자원 관리</a:t>
             </a:r>
             <a:endParaRPr lang="en-US" sz="1250" dirty="0"/>
           </a:p>
@@ -7759,7 +7760,7 @@
                 <a:ea typeface="Apple SD Gothic Neo" pitchFamily="34" charset="-122"/>
                 <a:cs typeface="Apple SD Gothic Neo" pitchFamily="34" charset="-120"/>
               </a:rPr>
-              <a:t>'덜 붐비는 나무'를 골라 둘레의 자기 자리로 — 군집 문제를 행동 설계로 해결</a:t>
+              <a:t>be_eaten()으로 먹힌 양을 풀 스스로 관리, 120틱 후 재성장. 풀 하나당 토끼 3마리 은신 한계</a:t>
             </a:r>
             <a:endParaRPr lang="en-US" sz="1250" dirty="0"/>
           </a:p>
@@ -7830,7 +7831,7 @@
                 <a:ea typeface="Apple SD Gothic Neo" pitchFamily="34" charset="-122"/>
                 <a:cs typeface="Apple SD Gothic Neo" pitchFamily="34" charset="-120"/>
               </a:rPr>
-              <a:t>🌿</a:t>
+              <a:t>🧬</a:t>
             </a:r>
             <a:endParaRPr lang="en-US" sz="2200" dirty="0"/>
           </a:p>
@@ -7869,7 +7870,7 @@
                 <a:ea typeface="Apple SD Gothic Neo" pitchFamily="34" charset="-122"/>
                 <a:cs typeface="Apple SD Gothic Neo" pitchFamily="34" charset="-120"/>
               </a:rPr>
-              <a:t>풀의 자원 관리</a:t>
+              <a:t>reproduce() — 한 번만 구현</a:t>
             </a:r>
             <a:endParaRPr lang="en-US" sz="1250" dirty="0"/>
           </a:p>
@@ -7886,7 +7887,7 @@
                 <a:ea typeface="Apple SD Gothic Neo" pitchFamily="34" charset="-122"/>
                 <a:cs typeface="Apple SD Gothic Neo" pitchFamily="34" charset="-120"/>
               </a:rPr>
-              <a:t>be_eaten()으로 먹힌 양을 풀 스스로 관리, 120틱 후 재성장</a:t>
+              <a:t>type(self)로 같은 종을 생성 — 토끼는 토끼를, 기린은 기린을. 자식마다 번식 코드가 필요 없다</a:t>
             </a:r>
             <a:endParaRPr lang="en-US" sz="1250" dirty="0"/>
           </a:p>
@@ -7960,7 +7961,7 @@
                 <a:ea typeface="Apple SD Gothic Neo" pitchFamily="34" charset="-122"/>
                 <a:cs typeface="Apple SD Gothic Neo" pitchFamily="34" charset="-120"/>
               </a:rPr>
-              <a:t>🖥 tkinter만으로 만든 GUI</a:t>
+              <a:t>🌳 번식터 분산 알고리즘</a:t>
             </a:r>
             <a:endParaRPr lang="en-US" sz="1400" dirty="0"/>
           </a:p>
@@ -7980,7 +7981,7 @@
                 <a:ea typeface="Apple SD Gothic Neo" pitchFamily="34" charset="-122"/>
                 <a:cs typeface="Apple SD Gothic Neo" pitchFamily="34" charset="-120"/>
               </a:rPr>
-              <a:t>after() 예약 방식의 게임 루프 — 매 프레임 world.step() 한 틱 + 다시 그리기 (초당 20프레임).</a:t>
+              <a:t>문제: 모두가 가장 가까운 나무 한곳에 몰려 화면이 겹쳐 보였다.</a:t>
             </a:r>
             <a:endParaRPr lang="en-US" sz="1400" dirty="0"/>
           </a:p>
@@ -7997,7 +7998,7 @@
                 <a:ea typeface="Apple SD Gothic Neo" pitchFamily="34" charset="-122"/>
                 <a:cs typeface="Apple SD Gothic Neo" pitchFamily="34" charset="-120"/>
               </a:rPr>
-              <a:t>체력바·기절 고리·은신 표시·개체 수 통계·생태계 일지로 모든 상호작용이 '눈에 보인다'. 한/영 키 문제까지 처리.</a:t>
+              <a:t>해결: 덜 붐비는 나무를 고르고, 나무 중심이 아닌 '둘레의 자기 자리'(개체별 선호 각도)로 — 번식 조건은 유지하고 군집만 풀었다.</a:t>
             </a:r>
             <a:endParaRPr lang="en-US" sz="1400" dirty="0"/>
           </a:p>
@@ -8068,7 +8069,7 @@
                 <a:ea typeface="Apple SD Gothic Neo" pitchFamily="34" charset="-122"/>
                 <a:cs typeface="Apple SD Gothic Neo" pitchFamily="34" charset="-120"/>
               </a:rPr>
-              <a:t>reproduce() — 책임 분리</a:t>
+              <a:t>Herbivore 공통 생존 흐름</a:t>
             </a:r>
             <a:endParaRPr lang="en-US" sz="1150" dirty="0"/>
           </a:p>
@@ -8085,7 +8086,7 @@
                 <a:ea typeface="Apple SD Gothic Neo" pitchFamily="34" charset="-122"/>
                 <a:cs typeface="Apple SD Gothic Neo" pitchFamily="34" charset="-120"/>
               </a:rPr>
-              <a:t>type(self)로 같은 종을 생성 — 토끼는 토끼를, 기린은 기린을 낳는다.</a:t>
+              <a:t>포식자가 가까우면 도망 → 배고프면 풀 → 준비되면 번식터로.</a:t>
             </a:r>
             <a:endParaRPr lang="en-US" sz="1150" dirty="0"/>
           </a:p>

</xml_diff>